<commit_message>
update to script, some figure tweaks
</commit_message>
<xml_diff>
--- a/figures/figure_01.pptx
+++ b/figures/figure_01.pptx
@@ -117,16 +117,32 @@
   <pc:docChgLst>
     <pc:chgData name="Gilbert, Neil" userId="37be9f5c-8f28-415b-96d6-624acf93bb3f" providerId="ADAL" clId="{18ED56B6-1921-416C-9A28-3F6F3C8390B5}"/>
     <pc:docChg chg="undo custSel modSld">
-      <pc:chgData name="Gilbert, Neil" userId="37be9f5c-8f28-415b-96d6-624acf93bb3f" providerId="ADAL" clId="{18ED56B6-1921-416C-9A28-3F6F3C8390B5}" dt="2026-08-26T16:02:42.937" v="436" actId="692"/>
+      <pc:chgData name="Gilbert, Neil" userId="37be9f5c-8f28-415b-96d6-624acf93bb3f" providerId="ADAL" clId="{18ED56B6-1921-416C-9A28-3F6F3C8390B5}" dt="2026-09-15T18:01:40.939" v="474" actId="692"/>
       <pc:docMkLst>
         <pc:docMk/>
       </pc:docMkLst>
       <pc:sldChg chg="addSp delSp modSp mod">
-        <pc:chgData name="Gilbert, Neil" userId="37be9f5c-8f28-415b-96d6-624acf93bb3f" providerId="ADAL" clId="{18ED56B6-1921-416C-9A28-3F6F3C8390B5}" dt="2026-08-26T16:02:42.937" v="436" actId="692"/>
+        <pc:chgData name="Gilbert, Neil" userId="37be9f5c-8f28-415b-96d6-624acf93bb3f" providerId="ADAL" clId="{18ED56B6-1921-416C-9A28-3F6F3C8390B5}" dt="2026-09-15T18:01:40.939" v="474" actId="692"/>
         <pc:sldMkLst>
           <pc:docMk/>
           <pc:sldMk cId="2153213621" sldId="256"/>
         </pc:sldMkLst>
+        <pc:spChg chg="add mod">
+          <ac:chgData name="Gilbert, Neil" userId="37be9f5c-8f28-415b-96d6-624acf93bb3f" providerId="ADAL" clId="{18ED56B6-1921-416C-9A28-3F6F3C8390B5}" dt="2026-09-08T17:44:54.138" v="445" actId="692"/>
+          <ac:spMkLst>
+            <pc:docMk/>
+            <pc:sldMk cId="2153213621" sldId="256"/>
+            <ac:spMk id="6" creationId="{69E8A909-6FB5-E326-CDB7-34156B6EB041}"/>
+          </ac:spMkLst>
+        </pc:spChg>
+        <pc:spChg chg="add mod">
+          <ac:chgData name="Gilbert, Neil" userId="37be9f5c-8f28-415b-96d6-624acf93bb3f" providerId="ADAL" clId="{18ED56B6-1921-416C-9A28-3F6F3C8390B5}" dt="2026-09-08T17:45:56.891" v="454" actId="692"/>
+          <ac:spMkLst>
+            <pc:docMk/>
+            <pc:sldMk cId="2153213621" sldId="256"/>
+            <ac:spMk id="15" creationId="{1A1EFCC9-8EA1-D804-D346-003775B27EFF}"/>
+          </ac:spMkLst>
+        </pc:spChg>
         <pc:spChg chg="mod">
           <ac:chgData name="Gilbert, Neil" userId="37be9f5c-8f28-415b-96d6-624acf93bb3f" providerId="ADAL" clId="{18ED56B6-1921-416C-9A28-3F6F3C8390B5}" dt="2026-08-26T16:02:42.937" v="436" actId="692"/>
           <ac:spMkLst>
@@ -143,6 +159,38 @@
             <ac:spMk id="20" creationId="{B72DE5EC-D1B6-ACA0-D773-649C3A22EBA6}"/>
           </ac:spMkLst>
         </pc:spChg>
+        <pc:spChg chg="add mod">
+          <ac:chgData name="Gilbert, Neil" userId="37be9f5c-8f28-415b-96d6-624acf93bb3f" providerId="ADAL" clId="{18ED56B6-1921-416C-9A28-3F6F3C8390B5}" dt="2026-09-08T17:47:39.774" v="472" actId="2085"/>
+          <ac:spMkLst>
+            <pc:docMk/>
+            <pc:sldMk cId="2153213621" sldId="256"/>
+            <ac:spMk id="22" creationId="{6A25B3B9-14EE-8630-2653-935783D04B53}"/>
+          </ac:spMkLst>
+        </pc:spChg>
+        <pc:spChg chg="mod">
+          <ac:chgData name="Gilbert, Neil" userId="37be9f5c-8f28-415b-96d6-624acf93bb3f" providerId="ADAL" clId="{18ED56B6-1921-416C-9A28-3F6F3C8390B5}" dt="2026-09-15T18:01:40.939" v="474" actId="692"/>
+          <ac:spMkLst>
+            <pc:docMk/>
+            <pc:sldMk cId="2153213621" sldId="256"/>
+            <ac:spMk id="24" creationId="{CE83FDB1-B5D1-82F1-D91D-5ED3180E5B73}"/>
+          </ac:spMkLst>
+        </pc:spChg>
+        <pc:picChg chg="add del">
+          <ac:chgData name="Gilbert, Neil" userId="37be9f5c-8f28-415b-96d6-624acf93bb3f" providerId="ADAL" clId="{18ED56B6-1921-416C-9A28-3F6F3C8390B5}" dt="2026-09-08T17:45:12.820" v="449" actId="21"/>
+          <ac:picMkLst>
+            <pc:docMk/>
+            <pc:sldMk cId="2153213621" sldId="256"/>
+            <ac:picMk id="3" creationId="{E3205EA8-87A9-71EE-E690-E0F18621E2B4}"/>
+          </ac:picMkLst>
+        </pc:picChg>
+        <pc:picChg chg="add mod ord modCrop">
+          <ac:chgData name="Gilbert, Neil" userId="37be9f5c-8f28-415b-96d6-624acf93bb3f" providerId="ADAL" clId="{18ED56B6-1921-416C-9A28-3F6F3C8390B5}" dt="2026-09-08T17:47:19.393" v="469" actId="1038"/>
+          <ac:picMkLst>
+            <pc:docMk/>
+            <pc:sldMk cId="2153213621" sldId="256"/>
+            <ac:picMk id="12" creationId="{EEAC2AE8-03E8-E3BB-E92F-145038098DFF}"/>
+          </ac:picMkLst>
+        </pc:picChg>
       </pc:sldChg>
     </pc:docChg>
   </pc:docChgLst>
@@ -280,7 +328,7 @@
           <a:p>
             <a:fld id="{A9B73ADB-E1A9-41CB-9D31-1DB388EE96E4}" type="datetimeFigureOut">
               <a:rPr lang="en-US" smtClean="0"/>
-              <a:t>8/26/2026</a:t>
+              <a:t>9/15/2026</a:t>
             </a:fld>
             <a:endParaRPr lang="en-US"/>
           </a:p>
@@ -450,7 +498,7 @@
           <a:p>
             <a:fld id="{A9B73ADB-E1A9-41CB-9D31-1DB388EE96E4}" type="datetimeFigureOut">
               <a:rPr lang="en-US" smtClean="0"/>
-              <a:t>8/26/2026</a:t>
+              <a:t>9/15/2026</a:t>
             </a:fld>
             <a:endParaRPr lang="en-US"/>
           </a:p>
@@ -630,7 +678,7 @@
           <a:p>
             <a:fld id="{A9B73ADB-E1A9-41CB-9D31-1DB388EE96E4}" type="datetimeFigureOut">
               <a:rPr lang="en-US" smtClean="0"/>
-              <a:t>8/26/2026</a:t>
+              <a:t>9/15/2026</a:t>
             </a:fld>
             <a:endParaRPr lang="en-US"/>
           </a:p>
@@ -800,7 +848,7 @@
           <a:p>
             <a:fld id="{A9B73ADB-E1A9-41CB-9D31-1DB388EE96E4}" type="datetimeFigureOut">
               <a:rPr lang="en-US" smtClean="0"/>
-              <a:t>8/26/2026</a:t>
+              <a:t>9/15/2026</a:t>
             </a:fld>
             <a:endParaRPr lang="en-US"/>
           </a:p>
@@ -1046,7 +1094,7 @@
           <a:p>
             <a:fld id="{A9B73ADB-E1A9-41CB-9D31-1DB388EE96E4}" type="datetimeFigureOut">
               <a:rPr lang="en-US" smtClean="0"/>
-              <a:t>8/26/2026</a:t>
+              <a:t>9/15/2026</a:t>
             </a:fld>
             <a:endParaRPr lang="en-US"/>
           </a:p>
@@ -1278,7 +1326,7 @@
           <a:p>
             <a:fld id="{A9B73ADB-E1A9-41CB-9D31-1DB388EE96E4}" type="datetimeFigureOut">
               <a:rPr lang="en-US" smtClean="0"/>
-              <a:t>8/26/2026</a:t>
+              <a:t>9/15/2026</a:t>
             </a:fld>
             <a:endParaRPr lang="en-US"/>
           </a:p>
@@ -1645,7 +1693,7 @@
           <a:p>
             <a:fld id="{A9B73ADB-E1A9-41CB-9D31-1DB388EE96E4}" type="datetimeFigureOut">
               <a:rPr lang="en-US" smtClean="0"/>
-              <a:t>8/26/2026</a:t>
+              <a:t>9/15/2026</a:t>
             </a:fld>
             <a:endParaRPr lang="en-US"/>
           </a:p>
@@ -1763,7 +1811,7 @@
           <a:p>
             <a:fld id="{A9B73ADB-E1A9-41CB-9D31-1DB388EE96E4}" type="datetimeFigureOut">
               <a:rPr lang="en-US" smtClean="0"/>
-              <a:t>8/26/2026</a:t>
+              <a:t>9/15/2026</a:t>
             </a:fld>
             <a:endParaRPr lang="en-US"/>
           </a:p>
@@ -1858,7 +1906,7 @@
           <a:p>
             <a:fld id="{A9B73ADB-E1A9-41CB-9D31-1DB388EE96E4}" type="datetimeFigureOut">
               <a:rPr lang="en-US" smtClean="0"/>
-              <a:t>8/26/2026</a:t>
+              <a:t>9/15/2026</a:t>
             </a:fld>
             <a:endParaRPr lang="en-US"/>
           </a:p>
@@ -2135,7 +2183,7 @@
           <a:p>
             <a:fld id="{A9B73ADB-E1A9-41CB-9D31-1DB388EE96E4}" type="datetimeFigureOut">
               <a:rPr lang="en-US" smtClean="0"/>
-              <a:t>8/26/2026</a:t>
+              <a:t>9/15/2026</a:t>
             </a:fld>
             <a:endParaRPr lang="en-US"/>
           </a:p>
@@ -2392,7 +2440,7 @@
           <a:p>
             <a:fld id="{A9B73ADB-E1A9-41CB-9D31-1DB388EE96E4}" type="datetimeFigureOut">
               <a:rPr lang="en-US" smtClean="0"/>
-              <a:t>8/26/2026</a:t>
+              <a:t>9/15/2026</a:t>
             </a:fld>
             <a:endParaRPr lang="en-US"/>
           </a:p>
@@ -2605,7 +2653,7 @@
           <a:p>
             <a:fld id="{A9B73ADB-E1A9-41CB-9D31-1DB388EE96E4}" type="datetimeFigureOut">
               <a:rPr lang="en-US" smtClean="0"/>
-              <a:t>8/26/2026</a:t>
+              <a:t>9/15/2026</a:t>
             </a:fld>
             <a:endParaRPr lang="en-US"/>
           </a:p>
@@ -4551,106 +4599,6 @@
                 </a:p>
               </p:txBody>
             </p:sp>
-            <p:sp>
-              <p:nvSpPr>
-                <p:cNvPr id="100" name="Freeform: Shape 99">
-                  <a:extLst>
-                    <a:ext uri="{FF2B5EF4-FFF2-40B4-BE49-F238E27FC236}">
-                      <a16:creationId xmlns:a16="http://schemas.microsoft.com/office/drawing/2014/main" id="{61387706-473C-9CFC-0078-BC793C5CEF80}"/>
-                    </a:ext>
-                  </a:extLst>
-                </p:cNvPr>
-                <p:cNvSpPr/>
-                <p:nvPr/>
-              </p:nvSpPr>
-              <p:spPr>
-                <a:xfrm>
-                  <a:off x="831300" y="2460019"/>
-                  <a:ext cx="748789" cy="577761"/>
-                </a:xfrm>
-                <a:custGeom>
-                  <a:avLst/>
-                  <a:gdLst>
-                    <a:gd name="connsiteX0" fmla="*/ 0 w 857905"/>
-                    <a:gd name="connsiteY0" fmla="*/ 0 h 647005"/>
-                    <a:gd name="connsiteX1" fmla="*/ 433388 w 857905"/>
-                    <a:gd name="connsiteY1" fmla="*/ 157163 h 647005"/>
-                    <a:gd name="connsiteX2" fmla="*/ 790575 w 857905"/>
-                    <a:gd name="connsiteY2" fmla="*/ 576263 h 647005"/>
-                    <a:gd name="connsiteX3" fmla="*/ 857250 w 857905"/>
-                    <a:gd name="connsiteY3" fmla="*/ 642938 h 647005"/>
-                  </a:gdLst>
-                  <a:ahLst/>
-                  <a:cxnLst>
-                    <a:cxn ang="0">
-                      <a:pos x="connsiteX0" y="connsiteY0"/>
-                    </a:cxn>
-                    <a:cxn ang="0">
-                      <a:pos x="connsiteX1" y="connsiteY1"/>
-                    </a:cxn>
-                    <a:cxn ang="0">
-                      <a:pos x="connsiteX2" y="connsiteY2"/>
-                    </a:cxn>
-                    <a:cxn ang="0">
-                      <a:pos x="connsiteX3" y="connsiteY3"/>
-                    </a:cxn>
-                  </a:cxnLst>
-                  <a:rect l="l" t="t" r="r" b="b"/>
-                  <a:pathLst>
-                    <a:path w="857905" h="647005">
-                      <a:moveTo>
-                        <a:pt x="0" y="0"/>
-                      </a:moveTo>
-                      <a:cubicBezTo>
-                        <a:pt x="150813" y="30559"/>
-                        <a:pt x="301626" y="61119"/>
-                        <a:pt x="433388" y="157163"/>
-                      </a:cubicBezTo>
-                      <a:cubicBezTo>
-                        <a:pt x="565150" y="253207"/>
-                        <a:pt x="719931" y="495301"/>
-                        <a:pt x="790575" y="576263"/>
-                      </a:cubicBezTo>
-                      <a:cubicBezTo>
-                        <a:pt x="861219" y="657225"/>
-                        <a:pt x="859234" y="650081"/>
-                        <a:pt x="857250" y="642938"/>
-                      </a:cubicBezTo>
-                    </a:path>
-                  </a:pathLst>
-                </a:custGeom>
-                <a:noFill/>
-                <a:ln w="38100">
-                  <a:solidFill>
-                    <a:srgbClr val="AE8548"/>
-                  </a:solidFill>
-                </a:ln>
-              </p:spPr>
-              <p:style>
-                <a:lnRef idx="2">
-                  <a:schemeClr val="accent1">
-                    <a:shade val="15000"/>
-                  </a:schemeClr>
-                </a:lnRef>
-                <a:fillRef idx="1">
-                  <a:schemeClr val="accent1"/>
-                </a:fillRef>
-                <a:effectRef idx="0">
-                  <a:schemeClr val="accent1"/>
-                </a:effectRef>
-                <a:fontRef idx="minor">
-                  <a:schemeClr val="lt1"/>
-                </a:fontRef>
-              </p:style>
-              <p:txBody>
-                <a:bodyPr rtlCol="0" anchor="ctr"/>
-                <a:lstStyle/>
-                <a:p>
-                  <a:pPr algn="ctr"/>
-                  <a:endParaRPr lang="en-US"/>
-                </a:p>
-              </p:txBody>
-            </p:sp>
           </p:grpSp>
         </p:grpSp>
         <p:sp>
@@ -6778,6 +6726,7 @@
             <a:solidFill>
               <a:schemeClr val="tx1"/>
             </a:solidFill>
+            <a:headEnd type="triangle" w="sm" len="sm"/>
             <a:tailEnd type="triangle" w="sm" len="sm"/>
           </a:ln>
         </p:spPr>
@@ -7260,6 +7209,420 @@
               <a:latin typeface="Arial" panose="020B0604020202020204" pitchFamily="34" charset="0"/>
               <a:cs typeface="Arial" panose="020B0604020202020204" pitchFamily="34" charset="0"/>
             </a:endParaRPr>
+          </a:p>
+        </p:txBody>
+      </p:sp>
+      <p:sp>
+        <p:nvSpPr>
+          <p:cNvPr id="6" name="Freeform: Shape 5">
+            <a:extLst>
+              <a:ext uri="{FF2B5EF4-FFF2-40B4-BE49-F238E27FC236}">
+                <a16:creationId xmlns:a16="http://schemas.microsoft.com/office/drawing/2014/main" id="{69E8A909-6FB5-E326-CDB7-34156B6EB041}"/>
+              </a:ext>
+            </a:extLst>
+          </p:cNvPr>
+          <p:cNvSpPr/>
+          <p:nvPr/>
+        </p:nvSpPr>
+        <p:spPr>
+          <a:xfrm>
+            <a:off x="304800" y="2324100"/>
+            <a:ext cx="707231" cy="619125"/>
+          </a:xfrm>
+          <a:custGeom>
+            <a:avLst/>
+            <a:gdLst>
+              <a:gd name="csX0" fmla="*/ 0 w 707231"/>
+              <a:gd name="csY0" fmla="*/ 0 h 619125"/>
+              <a:gd name="csX1" fmla="*/ 414338 w 707231"/>
+              <a:gd name="csY1" fmla="*/ 159544 h 619125"/>
+              <a:gd name="csX2" fmla="*/ 640556 w 707231"/>
+              <a:gd name="csY2" fmla="*/ 531019 h 619125"/>
+              <a:gd name="csX3" fmla="*/ 707231 w 707231"/>
+              <a:gd name="csY3" fmla="*/ 619125 h 619125"/>
+            </a:gdLst>
+            <a:ahLst/>
+            <a:cxnLst>
+              <a:cxn ang="0">
+                <a:pos x="csX0" y="csY0"/>
+              </a:cxn>
+              <a:cxn ang="0">
+                <a:pos x="csX1" y="csY1"/>
+              </a:cxn>
+              <a:cxn ang="0">
+                <a:pos x="csX2" y="csY2"/>
+              </a:cxn>
+              <a:cxn ang="0">
+                <a:pos x="csX3" y="csY3"/>
+              </a:cxn>
+            </a:cxnLst>
+            <a:rect l="l" t="t" r="r" b="b"/>
+            <a:pathLst>
+              <a:path w="707231" h="619125">
+                <a:moveTo>
+                  <a:pt x="0" y="0"/>
+                </a:moveTo>
+                <a:cubicBezTo>
+                  <a:pt x="153789" y="35520"/>
+                  <a:pt x="307579" y="71041"/>
+                  <a:pt x="414338" y="159544"/>
+                </a:cubicBezTo>
+                <a:cubicBezTo>
+                  <a:pt x="521097" y="248047"/>
+                  <a:pt x="591741" y="454422"/>
+                  <a:pt x="640556" y="531019"/>
+                </a:cubicBezTo>
+                <a:cubicBezTo>
+                  <a:pt x="689371" y="607616"/>
+                  <a:pt x="698301" y="613370"/>
+                  <a:pt x="707231" y="619125"/>
+                </a:cubicBezTo>
+              </a:path>
+            </a:pathLst>
+          </a:custGeom>
+          <a:noFill/>
+          <a:ln w="38100">
+            <a:solidFill>
+              <a:srgbClr val="AE8548"/>
+            </a:solidFill>
+          </a:ln>
+        </p:spPr>
+        <p:style>
+          <a:lnRef idx="2">
+            <a:schemeClr val="accent1">
+              <a:shade val="15000"/>
+            </a:schemeClr>
+          </a:lnRef>
+          <a:fillRef idx="1">
+            <a:schemeClr val="accent1"/>
+          </a:fillRef>
+          <a:effectRef idx="0">
+            <a:schemeClr val="accent1"/>
+          </a:effectRef>
+          <a:fontRef idx="minor">
+            <a:schemeClr val="lt1"/>
+          </a:fontRef>
+        </p:style>
+        <p:txBody>
+          <a:bodyPr rtlCol="0" anchor="ctr"/>
+          <a:lstStyle/>
+          <a:p>
+            <a:pPr algn="ctr"/>
+            <a:endParaRPr lang="en-US"/>
+          </a:p>
+        </p:txBody>
+      </p:sp>
+      <p:sp>
+        <p:nvSpPr>
+          <p:cNvPr id="15" name="Freeform: Shape 14">
+            <a:extLst>
+              <a:ext uri="{FF2B5EF4-FFF2-40B4-BE49-F238E27FC236}">
+                <a16:creationId xmlns:a16="http://schemas.microsoft.com/office/drawing/2014/main" id="{1A1EFCC9-8EA1-D804-D346-003775B27EFF}"/>
+              </a:ext>
+            </a:extLst>
+          </p:cNvPr>
+          <p:cNvSpPr/>
+          <p:nvPr/>
+        </p:nvSpPr>
+        <p:spPr>
+          <a:xfrm>
+            <a:off x="1716881" y="728663"/>
+            <a:ext cx="545307" cy="1019175"/>
+          </a:xfrm>
+          <a:custGeom>
+            <a:avLst/>
+            <a:gdLst>
+              <a:gd name="csX0" fmla="*/ 0 w 545307"/>
+              <a:gd name="csY0" fmla="*/ 290512 h 1019175"/>
+              <a:gd name="csX1" fmla="*/ 69057 w 545307"/>
+              <a:gd name="csY1" fmla="*/ 228600 h 1019175"/>
+              <a:gd name="csX2" fmla="*/ 33338 w 545307"/>
+              <a:gd name="csY2" fmla="*/ 188118 h 1019175"/>
+              <a:gd name="csX3" fmla="*/ 80963 w 545307"/>
+              <a:gd name="csY3" fmla="*/ 157162 h 1019175"/>
+              <a:gd name="csX4" fmla="*/ 78582 w 545307"/>
+              <a:gd name="csY4" fmla="*/ 26193 h 1019175"/>
+              <a:gd name="csX5" fmla="*/ 188119 w 545307"/>
+              <a:gd name="csY5" fmla="*/ 0 h 1019175"/>
+              <a:gd name="csX6" fmla="*/ 445294 w 545307"/>
+              <a:gd name="csY6" fmla="*/ 142875 h 1019175"/>
+              <a:gd name="csX7" fmla="*/ 533400 w 545307"/>
+              <a:gd name="csY7" fmla="*/ 428625 h 1019175"/>
+              <a:gd name="csX8" fmla="*/ 542925 w 545307"/>
+              <a:gd name="csY8" fmla="*/ 823912 h 1019175"/>
+              <a:gd name="csX9" fmla="*/ 545307 w 545307"/>
+              <a:gd name="csY9" fmla="*/ 954881 h 1019175"/>
+              <a:gd name="csX10" fmla="*/ 214313 w 545307"/>
+              <a:gd name="csY10" fmla="*/ 1019175 h 1019175"/>
+              <a:gd name="csX11" fmla="*/ 80963 w 545307"/>
+              <a:gd name="csY11" fmla="*/ 885825 h 1019175"/>
+              <a:gd name="csX12" fmla="*/ 0 w 545307"/>
+              <a:gd name="csY12" fmla="*/ 290512 h 1019175"/>
+            </a:gdLst>
+            <a:ahLst/>
+            <a:cxnLst>
+              <a:cxn ang="0">
+                <a:pos x="csX0" y="csY0"/>
+              </a:cxn>
+              <a:cxn ang="0">
+                <a:pos x="csX1" y="csY1"/>
+              </a:cxn>
+              <a:cxn ang="0">
+                <a:pos x="csX2" y="csY2"/>
+              </a:cxn>
+              <a:cxn ang="0">
+                <a:pos x="csX3" y="csY3"/>
+              </a:cxn>
+              <a:cxn ang="0">
+                <a:pos x="csX4" y="csY4"/>
+              </a:cxn>
+              <a:cxn ang="0">
+                <a:pos x="csX5" y="csY5"/>
+              </a:cxn>
+              <a:cxn ang="0">
+                <a:pos x="csX6" y="csY6"/>
+              </a:cxn>
+              <a:cxn ang="0">
+                <a:pos x="csX7" y="csY7"/>
+              </a:cxn>
+              <a:cxn ang="0">
+                <a:pos x="csX8" y="csY8"/>
+              </a:cxn>
+              <a:cxn ang="0">
+                <a:pos x="csX9" y="csY9"/>
+              </a:cxn>
+              <a:cxn ang="0">
+                <a:pos x="csX10" y="csY10"/>
+              </a:cxn>
+              <a:cxn ang="0">
+                <a:pos x="csX11" y="csY11"/>
+              </a:cxn>
+              <a:cxn ang="0">
+                <a:pos x="csX12" y="csY12"/>
+              </a:cxn>
+            </a:cxnLst>
+            <a:rect l="l" t="t" r="r" b="b"/>
+            <a:pathLst>
+              <a:path w="545307" h="1019175">
+                <a:moveTo>
+                  <a:pt x="0" y="290512"/>
+                </a:moveTo>
+                <a:lnTo>
+                  <a:pt x="69057" y="228600"/>
+                </a:lnTo>
+                <a:lnTo>
+                  <a:pt x="33338" y="188118"/>
+                </a:lnTo>
+                <a:lnTo>
+                  <a:pt x="80963" y="157162"/>
+                </a:lnTo>
+                <a:cubicBezTo>
+                  <a:pt x="80169" y="113506"/>
+                  <a:pt x="79376" y="69849"/>
+                  <a:pt x="78582" y="26193"/>
+                </a:cubicBezTo>
+                <a:lnTo>
+                  <a:pt x="188119" y="0"/>
+                </a:lnTo>
+                <a:lnTo>
+                  <a:pt x="445294" y="142875"/>
+                </a:lnTo>
+                <a:lnTo>
+                  <a:pt x="533400" y="428625"/>
+                </a:lnTo>
+                <a:lnTo>
+                  <a:pt x="542925" y="823912"/>
+                </a:lnTo>
+                <a:lnTo>
+                  <a:pt x="545307" y="954881"/>
+                </a:lnTo>
+                <a:lnTo>
+                  <a:pt x="214313" y="1019175"/>
+                </a:lnTo>
+                <a:lnTo>
+                  <a:pt x="80963" y="885825"/>
+                </a:lnTo>
+                <a:lnTo>
+                  <a:pt x="0" y="290512"/>
+                </a:lnTo>
+                <a:close/>
+              </a:path>
+            </a:pathLst>
+          </a:custGeom>
+          <a:solidFill>
+            <a:schemeClr val="bg1"/>
+          </a:solidFill>
+          <a:ln>
+            <a:solidFill>
+              <a:schemeClr val="bg1"/>
+            </a:solidFill>
+          </a:ln>
+        </p:spPr>
+        <p:style>
+          <a:lnRef idx="2">
+            <a:schemeClr val="accent1">
+              <a:shade val="15000"/>
+            </a:schemeClr>
+          </a:lnRef>
+          <a:fillRef idx="1">
+            <a:schemeClr val="accent1"/>
+          </a:fillRef>
+          <a:effectRef idx="0">
+            <a:schemeClr val="accent1"/>
+          </a:effectRef>
+          <a:fontRef idx="minor">
+            <a:schemeClr val="lt1"/>
+          </a:fontRef>
+        </p:style>
+        <p:txBody>
+          <a:bodyPr rtlCol="0" anchor="ctr"/>
+          <a:lstStyle/>
+          <a:p>
+            <a:pPr algn="ctr"/>
+            <a:endParaRPr lang="en-US"/>
+          </a:p>
+        </p:txBody>
+      </p:sp>
+      <p:pic>
+        <p:nvPicPr>
+          <p:cNvPr id="12" name="Picture 11">
+            <a:extLst>
+              <a:ext uri="{FF2B5EF4-FFF2-40B4-BE49-F238E27FC236}">
+                <a16:creationId xmlns:a16="http://schemas.microsoft.com/office/drawing/2014/main" id="{EEAC2AE8-03E8-E3BB-E92F-145038098DFF}"/>
+              </a:ext>
+            </a:extLst>
+          </p:cNvPr>
+          <p:cNvPicPr>
+            <a:picLocks noChangeAspect="1"/>
+          </p:cNvPicPr>
+          <p:nvPr/>
+        </p:nvPicPr>
+        <p:blipFill>
+          <a:blip r:embed="rId5">
+            <a:extLst>
+              <a:ext uri="{28A0092B-C50C-407E-A947-70E740481C1C}">
+                <a14:useLocalDpi xmlns:a14="http://schemas.microsoft.com/office/drawing/2010/main" val="0"/>
+              </a:ext>
+            </a:extLst>
+          </a:blip>
+          <a:srcRect l="75925" t="36494" r="1081" b="19851"/>
+          <a:stretch>
+            <a:fillRect/>
+          </a:stretch>
+        </p:blipFill>
+        <p:spPr>
+          <a:xfrm>
+            <a:off x="1833377" y="841050"/>
+            <a:ext cx="393192" cy="746450"/>
+          </a:xfrm>
+          <a:prstGeom prst="rect">
+            <a:avLst/>
+          </a:prstGeom>
+          <a:ln w="6350">
+            <a:noFill/>
+          </a:ln>
+        </p:spPr>
+      </p:pic>
+      <p:sp>
+        <p:nvSpPr>
+          <p:cNvPr id="22" name="Freeform: Shape 21">
+            <a:extLst>
+              <a:ext uri="{FF2B5EF4-FFF2-40B4-BE49-F238E27FC236}">
+                <a16:creationId xmlns:a16="http://schemas.microsoft.com/office/drawing/2014/main" id="{6A25B3B9-14EE-8630-2653-935783D04B53}"/>
+              </a:ext>
+            </a:extLst>
+          </p:cNvPr>
+          <p:cNvSpPr/>
+          <p:nvPr/>
+        </p:nvSpPr>
+        <p:spPr>
+          <a:xfrm>
+            <a:off x="1766888" y="1423988"/>
+            <a:ext cx="219075" cy="276225"/>
+          </a:xfrm>
+          <a:custGeom>
+            <a:avLst/>
+            <a:gdLst>
+              <a:gd name="csX0" fmla="*/ 14287 w 219075"/>
+              <a:gd name="csY0" fmla="*/ 0 h 276225"/>
+              <a:gd name="csX1" fmla="*/ 219075 w 219075"/>
+              <a:gd name="csY1" fmla="*/ 223837 h 276225"/>
+              <a:gd name="csX2" fmla="*/ 104775 w 219075"/>
+              <a:gd name="csY2" fmla="*/ 276225 h 276225"/>
+              <a:gd name="csX3" fmla="*/ 0 w 219075"/>
+              <a:gd name="csY3" fmla="*/ 104775 h 276225"/>
+              <a:gd name="csX4" fmla="*/ 14287 w 219075"/>
+              <a:gd name="csY4" fmla="*/ 0 h 276225"/>
+            </a:gdLst>
+            <a:ahLst/>
+            <a:cxnLst>
+              <a:cxn ang="0">
+                <a:pos x="csX0" y="csY0"/>
+              </a:cxn>
+              <a:cxn ang="0">
+                <a:pos x="csX1" y="csY1"/>
+              </a:cxn>
+              <a:cxn ang="0">
+                <a:pos x="csX2" y="csY2"/>
+              </a:cxn>
+              <a:cxn ang="0">
+                <a:pos x="csX3" y="csY3"/>
+              </a:cxn>
+              <a:cxn ang="0">
+                <a:pos x="csX4" y="csY4"/>
+              </a:cxn>
+            </a:cxnLst>
+            <a:rect l="l" t="t" r="r" b="b"/>
+            <a:pathLst>
+              <a:path w="219075" h="276225">
+                <a:moveTo>
+                  <a:pt x="14287" y="0"/>
+                </a:moveTo>
+                <a:lnTo>
+                  <a:pt x="219075" y="223837"/>
+                </a:lnTo>
+                <a:lnTo>
+                  <a:pt x="104775" y="276225"/>
+                </a:lnTo>
+                <a:lnTo>
+                  <a:pt x="0" y="104775"/>
+                </a:lnTo>
+                <a:lnTo>
+                  <a:pt x="14287" y="0"/>
+                </a:lnTo>
+                <a:close/>
+              </a:path>
+            </a:pathLst>
+          </a:custGeom>
+          <a:solidFill>
+            <a:schemeClr val="bg1"/>
+          </a:solidFill>
+          <a:ln>
+            <a:noFill/>
+          </a:ln>
+        </p:spPr>
+        <p:style>
+          <a:lnRef idx="2">
+            <a:schemeClr val="accent1">
+              <a:shade val="15000"/>
+            </a:schemeClr>
+          </a:lnRef>
+          <a:fillRef idx="1">
+            <a:schemeClr val="accent1"/>
+          </a:fillRef>
+          <a:effectRef idx="0">
+            <a:schemeClr val="accent1"/>
+          </a:effectRef>
+          <a:fontRef idx="minor">
+            <a:schemeClr val="lt1"/>
+          </a:fontRef>
+        </p:style>
+        <p:txBody>
+          <a:bodyPr rtlCol="0" anchor="ctr"/>
+          <a:lstStyle/>
+          <a:p>
+            <a:pPr algn="ctr"/>
+            <a:endParaRPr lang="en-US"/>
           </a:p>
         </p:txBody>
       </p:sp>

</xml_diff>